<commit_message>
Update README links and add presentation files to docs Inital work for #110
</commit_message>
<xml_diff>
--- a/docs/Prototype.pptx
+++ b/docs/Prototype.pptx
@@ -5,7 +5,7 @@
     <p:sldMasterId id="2147483648" r:id="rId1"/>
   </p:sldMasterIdLst>
   <p:notesMasterIdLst>
-    <p:notesMasterId r:id="rId14"/>
+    <p:notesMasterId r:id="rId17"/>
   </p:notesMasterIdLst>
   <p:sldIdLst>
     <p:sldId id="256" r:id="rId2"/>
@@ -20,6 +20,9 @@
     <p:sldId id="265" r:id="rId11"/>
     <p:sldId id="266" r:id="rId12"/>
     <p:sldId id="267" r:id="rId13"/>
+    <p:sldId id="268" r:id="rId14"/>
+    <p:sldId id="269" r:id="rId15"/>
+    <p:sldId id="270" r:id="rId16"/>
   </p:sldIdLst>
   <p:sldSz cx="12192000" cy="6858000"/>
   <p:notesSz cx="6858000" cy="9144000"/>
@@ -208,7 +211,7 @@
           <a:p>
             <a:fld id="{3635DB15-7D6E-4472-B99D-9906CF1DE234}" type="datetimeFigureOut">
               <a:rPr lang="en-US" smtClean="0"/>
-              <a:t>8/19/2026</a:t>
+              <a:t>9/21/2026</a:t>
             </a:fld>
             <a:endParaRPr lang="en-US"/>
           </a:p>
@@ -1630,7 +1633,7 @@
           <a:p>
             <a:fld id="{DD5FEBA2-C475-4F4F-B1DA-6AC3BCF25491}" type="datetimeFigureOut">
               <a:rPr lang="en-US" smtClean="0"/>
-              <a:t>8/19/2026</a:t>
+              <a:t>9/21/2026</a:t>
             </a:fld>
             <a:endParaRPr lang="en-US"/>
           </a:p>
@@ -1828,7 +1831,7 @@
           <a:p>
             <a:fld id="{DD5FEBA2-C475-4F4F-B1DA-6AC3BCF25491}" type="datetimeFigureOut">
               <a:rPr lang="en-US" smtClean="0"/>
-              <a:t>8/19/2026</a:t>
+              <a:t>9/21/2026</a:t>
             </a:fld>
             <a:endParaRPr lang="en-US"/>
           </a:p>
@@ -2036,7 +2039,7 @@
           <a:p>
             <a:fld id="{DD5FEBA2-C475-4F4F-B1DA-6AC3BCF25491}" type="datetimeFigureOut">
               <a:rPr lang="en-US" smtClean="0"/>
-              <a:t>8/19/2026</a:t>
+              <a:t>9/21/2026</a:t>
             </a:fld>
             <a:endParaRPr lang="en-US"/>
           </a:p>
@@ -2269,7 +2272,7 @@
           <a:p>
             <a:fld id="{DD5FEBA2-C475-4F4F-B1DA-6AC3BCF25491}" type="datetimeFigureOut">
               <a:rPr lang="en-US" smtClean="0"/>
-              <a:t>8/19/2026</a:t>
+              <a:t>9/21/2026</a:t>
             </a:fld>
             <a:endParaRPr lang="en-US"/>
           </a:p>
@@ -2544,7 +2547,7 @@
           <a:p>
             <a:fld id="{DD5FEBA2-C475-4F4F-B1DA-6AC3BCF25491}" type="datetimeFigureOut">
               <a:rPr lang="en-US" smtClean="0"/>
-              <a:t>8/19/2026</a:t>
+              <a:t>9/21/2026</a:t>
             </a:fld>
             <a:endParaRPr lang="en-US"/>
           </a:p>
@@ -2809,7 +2812,7 @@
           <a:p>
             <a:fld id="{DD5FEBA2-C475-4F4F-B1DA-6AC3BCF25491}" type="datetimeFigureOut">
               <a:rPr lang="en-US" smtClean="0"/>
-              <a:t>8/19/2026</a:t>
+              <a:t>9/21/2026</a:t>
             </a:fld>
             <a:endParaRPr lang="en-US"/>
           </a:p>
@@ -3221,7 +3224,7 @@
           <a:p>
             <a:fld id="{DD5FEBA2-C475-4F4F-B1DA-6AC3BCF25491}" type="datetimeFigureOut">
               <a:rPr lang="en-US" smtClean="0"/>
-              <a:t>8/19/2026</a:t>
+              <a:t>9/21/2026</a:t>
             </a:fld>
             <a:endParaRPr lang="en-US"/>
           </a:p>
@@ -3362,7 +3365,7 @@
           <a:p>
             <a:fld id="{DD5FEBA2-C475-4F4F-B1DA-6AC3BCF25491}" type="datetimeFigureOut">
               <a:rPr lang="en-US" smtClean="0"/>
-              <a:t>8/19/2026</a:t>
+              <a:t>9/21/2026</a:t>
             </a:fld>
             <a:endParaRPr lang="en-US"/>
           </a:p>
@@ -3475,7 +3478,7 @@
           <a:p>
             <a:fld id="{DD5FEBA2-C475-4F4F-B1DA-6AC3BCF25491}" type="datetimeFigureOut">
               <a:rPr lang="en-US" smtClean="0"/>
-              <a:t>8/19/2026</a:t>
+              <a:t>9/21/2026</a:t>
             </a:fld>
             <a:endParaRPr lang="en-US"/>
           </a:p>
@@ -3786,7 +3789,7 @@
           <a:p>
             <a:fld id="{DD5FEBA2-C475-4F4F-B1DA-6AC3BCF25491}" type="datetimeFigureOut">
               <a:rPr lang="en-US" smtClean="0"/>
-              <a:t>8/19/2026</a:t>
+              <a:t>9/21/2026</a:t>
             </a:fld>
             <a:endParaRPr lang="en-US"/>
           </a:p>
@@ -4074,7 +4077,7 @@
           <a:p>
             <a:fld id="{DD5FEBA2-C475-4F4F-B1DA-6AC3BCF25491}" type="datetimeFigureOut">
               <a:rPr lang="en-US" smtClean="0"/>
-              <a:t>8/19/2026</a:t>
+              <a:t>9/21/2026</a:t>
             </a:fld>
             <a:endParaRPr lang="en-US"/>
           </a:p>
@@ -4315,7 +4318,7 @@
           <a:p>
             <a:fld id="{DD5FEBA2-C475-4F4F-B1DA-6AC3BCF25491}" type="datetimeFigureOut">
               <a:rPr lang="en-US" smtClean="0"/>
-              <a:t>8/19/2026</a:t>
+              <a:t>9/21/2026</a:t>
             </a:fld>
             <a:endParaRPr lang="en-US"/>
           </a:p>
@@ -13915,6 +13918,658 @@
         </p:txBody>
       </p:sp>
     </p:spTree>
+  </p:cSld>
+  <p:clrMapOvr>
+    <a:masterClrMapping/>
+  </p:clrMapOvr>
+</p:sld>
+</file>
+
+<file path=ppt/slides/slide13.xml><?xml version="1.0" encoding="utf-8"?>
+<p:sld xmlns:a="http://schemas.openxmlformats.org/drawingml/2006/main" xmlns:r="http://schemas.openxmlformats.org/officeDocument/2006/relationships" xmlns:p="http://schemas.openxmlformats.org/presentationml/2006/main">
+  <p:cSld>
+    <p:spTree>
+      <p:nvGrpSpPr>
+        <p:cNvPr id="1" name=""/>
+        <p:cNvGrpSpPr/>
+        <p:nvPr/>
+      </p:nvGrpSpPr>
+      <p:grpSpPr>
+        <a:xfrm>
+          <a:off x="0" y="0"/>
+          <a:ext cx="0" cy="0"/>
+          <a:chOff x="0" y="0"/>
+          <a:chExt cx="0" cy="0"/>
+        </a:xfrm>
+      </p:grpSpPr>
+      <p:sp>
+        <p:nvSpPr>
+          <p:cNvPr id="2" name="TextBox 1">
+            <a:extLst>
+              <a:ext uri="{FF2B5EF4-FFF2-40B4-BE49-F238E27FC236}">
+                <a16:creationId xmlns:a16="http://schemas.microsoft.com/office/drawing/2014/main" id="{B11A5918-99AF-6C39-B685-05D56B64D7E2}"/>
+              </a:ext>
+            </a:extLst>
+          </p:cNvPr>
+          <p:cNvSpPr txBox="1"/>
+          <p:nvPr/>
+        </p:nvSpPr>
+        <p:spPr>
+          <a:xfrm>
+            <a:off x="1179576" y="713232"/>
+            <a:ext cx="611065" cy="369332"/>
+          </a:xfrm>
+          <a:prstGeom prst="rect">
+            <a:avLst/>
+          </a:prstGeom>
+          <a:noFill/>
+        </p:spPr>
+        <p:txBody>
+          <a:bodyPr wrap="none" rtlCol="0">
+            <a:spAutoFit/>
+          </a:bodyPr>
+          <a:lstStyle/>
+          <a:p>
+            <a:r>
+              <a:rPr lang="en-US" dirty="0"/>
+              <a:t>ERD</a:t>
+            </a:r>
+          </a:p>
+        </p:txBody>
+      </p:sp>
+      <p:pic>
+        <p:nvPicPr>
+          <p:cNvPr id="6" name="Picture 5">
+            <a:extLst>
+              <a:ext uri="{FF2B5EF4-FFF2-40B4-BE49-F238E27FC236}">
+                <a16:creationId xmlns:a16="http://schemas.microsoft.com/office/drawing/2014/main" id="{5762FB90-FE35-F282-DBA2-FB2E6AC7924F}"/>
+              </a:ext>
+            </a:extLst>
+          </p:cNvPr>
+          <p:cNvPicPr>
+            <a:picLocks noChangeAspect="1"/>
+          </p:cNvPicPr>
+          <p:nvPr/>
+        </p:nvPicPr>
+        <p:blipFill>
+          <a:blip r:embed="rId2"/>
+          <a:stretch>
+            <a:fillRect/>
+          </a:stretch>
+        </p:blipFill>
+        <p:spPr>
+          <a:xfrm>
+            <a:off x="5291471" y="358845"/>
+            <a:ext cx="6144482" cy="6268325"/>
+          </a:xfrm>
+          <a:prstGeom prst="rect">
+            <a:avLst/>
+          </a:prstGeom>
+        </p:spPr>
+      </p:pic>
+    </p:spTree>
+    <p:extLst>
+      <p:ext uri="{BB962C8B-B14F-4D97-AF65-F5344CB8AC3E}">
+        <p14:creationId xmlns:p14="http://schemas.microsoft.com/office/powerpoint/2010/main" val="4215458631"/>
+      </p:ext>
+    </p:extLst>
+  </p:cSld>
+  <p:clrMapOvr>
+    <a:masterClrMapping/>
+  </p:clrMapOvr>
+</p:sld>
+</file>
+
+<file path=ppt/slides/slide14.xml><?xml version="1.0" encoding="utf-8"?>
+<p:sld xmlns:a="http://schemas.openxmlformats.org/drawingml/2006/main" xmlns:r="http://schemas.openxmlformats.org/officeDocument/2006/relationships" xmlns:p="http://schemas.openxmlformats.org/presentationml/2006/main">
+  <p:cSld>
+    <p:spTree>
+      <p:nvGrpSpPr>
+        <p:cNvPr id="1" name=""/>
+        <p:cNvGrpSpPr/>
+        <p:nvPr/>
+      </p:nvGrpSpPr>
+      <p:grpSpPr>
+        <a:xfrm>
+          <a:off x="0" y="0"/>
+          <a:ext cx="0" cy="0"/>
+          <a:chOff x="0" y="0"/>
+          <a:chExt cx="0" cy="0"/>
+        </a:xfrm>
+      </p:grpSpPr>
+      <p:sp>
+        <p:nvSpPr>
+          <p:cNvPr id="3" name="Title 2">
+            <a:extLst>
+              <a:ext uri="{FF2B5EF4-FFF2-40B4-BE49-F238E27FC236}">
+                <a16:creationId xmlns:a16="http://schemas.microsoft.com/office/drawing/2014/main" id="{F0D51221-4031-16CF-9492-E5678E8C135F}"/>
+              </a:ext>
+            </a:extLst>
+          </p:cNvPr>
+          <p:cNvSpPr>
+            <a:spLocks noGrp="1"/>
+          </p:cNvSpPr>
+          <p:nvPr>
+            <p:ph type="title"/>
+          </p:nvPr>
+        </p:nvSpPr>
+        <p:spPr/>
+        <p:txBody>
+          <a:bodyPr/>
+          <a:lstStyle/>
+          <a:p>
+            <a:r>
+              <a:rPr lang="en-US" dirty="0"/>
+              <a:t>Tests Created</a:t>
+            </a:r>
+          </a:p>
+        </p:txBody>
+      </p:sp>
+      <p:graphicFrame>
+        <p:nvGraphicFramePr>
+          <p:cNvPr id="8" name="Table 7">
+            <a:extLst>
+              <a:ext uri="{FF2B5EF4-FFF2-40B4-BE49-F238E27FC236}">
+                <a16:creationId xmlns:a16="http://schemas.microsoft.com/office/drawing/2014/main" id="{E6BBA3F8-CF92-0CAE-DA0B-BEA11696DE8D}"/>
+              </a:ext>
+            </a:extLst>
+          </p:cNvPr>
+          <p:cNvGraphicFramePr>
+            <a:graphicFrameLocks noGrp="1"/>
+          </p:cNvGraphicFramePr>
+          <p:nvPr>
+            <p:extLst>
+              <p:ext uri="{D42A27DB-BD31-4B8C-83A1-F6EECF244321}">
+                <p14:modId xmlns:p14="http://schemas.microsoft.com/office/powerpoint/2010/main" val="3433709969"/>
+              </p:ext>
+            </p:extLst>
+          </p:nvPr>
+        </p:nvGraphicFramePr>
+        <p:xfrm>
+          <a:off x="836612" y="1570058"/>
+          <a:ext cx="10648252" cy="4766736"/>
+        </p:xfrm>
+        <a:graphic>
+          <a:graphicData uri="http://schemas.openxmlformats.org/drawingml/2006/table">
+            <a:tbl>
+              <a:tblPr firstRow="1" bandRow="1">
+                <a:tableStyleId>{5C22544A-7EE6-4342-B048-85BDC9FD1C3A}</a:tableStyleId>
+              </a:tblPr>
+              <a:tblGrid>
+                <a:gridCol w="5324126">
+                  <a:extLst>
+                    <a:ext uri="{9D8B030D-6E8A-4147-A177-3AD203B41FA5}">
+                      <a16:colId xmlns:a16="http://schemas.microsoft.com/office/drawing/2014/main" val="1350263101"/>
+                    </a:ext>
+                  </a:extLst>
+                </a:gridCol>
+                <a:gridCol w="5324126">
+                  <a:extLst>
+                    <a:ext uri="{9D8B030D-6E8A-4147-A177-3AD203B41FA5}">
+                      <a16:colId xmlns:a16="http://schemas.microsoft.com/office/drawing/2014/main" val="1308490610"/>
+                    </a:ext>
+                  </a:extLst>
+                </a:gridCol>
+              </a:tblGrid>
+              <a:tr h="794456">
+                <a:tc>
+                  <a:txBody>
+                    <a:bodyPr/>
+                    <a:lstStyle/>
+                    <a:p>
+                      <a:r>
+                        <a:rPr lang="en-US" dirty="0"/>
+                        <a:t>Test Name/Description</a:t>
+                      </a:r>
+                    </a:p>
+                  </a:txBody>
+                  <a:tcPr/>
+                </a:tc>
+                <a:tc>
+                  <a:txBody>
+                    <a:bodyPr/>
+                    <a:lstStyle/>
+                    <a:p>
+                      <a:r>
+                        <a:rPr lang="en-US" dirty="0"/>
+                        <a:t>Result</a:t>
+                      </a:r>
+                    </a:p>
+                  </a:txBody>
+                  <a:tcPr/>
+                </a:tc>
+                <a:extLst>
+                  <a:ext uri="{0D108BD9-81ED-4DB2-BD59-A6C34878D82A}">
+                    <a16:rowId xmlns:a16="http://schemas.microsoft.com/office/drawing/2014/main" val="1949477541"/>
+                  </a:ext>
+                </a:extLst>
+              </a:tr>
+              <a:tr h="794456">
+                <a:tc>
+                  <a:txBody>
+                    <a:bodyPr/>
+                    <a:lstStyle/>
+                    <a:p>
+                      <a:r>
+                        <a:rPr lang="en-US" dirty="0"/>
+                        <a:t>Verify Reservation Lookup Connects to the Database</a:t>
+                      </a:r>
+                    </a:p>
+                  </a:txBody>
+                  <a:tcPr/>
+                </a:tc>
+                <a:tc>
+                  <a:txBody>
+                    <a:bodyPr/>
+                    <a:lstStyle/>
+                    <a:p>
+                      <a:endParaRPr lang="en-US" dirty="0"/>
+                    </a:p>
+                  </a:txBody>
+                  <a:tcPr/>
+                </a:tc>
+                <a:extLst>
+                  <a:ext uri="{0D108BD9-81ED-4DB2-BD59-A6C34878D82A}">
+                    <a16:rowId xmlns:a16="http://schemas.microsoft.com/office/drawing/2014/main" val="3627560426"/>
+                  </a:ext>
+                </a:extLst>
+              </a:tr>
+              <a:tr h="794456">
+                <a:tc>
+                  <a:txBody>
+                    <a:bodyPr/>
+                    <a:lstStyle/>
+                    <a:p>
+                      <a:r>
+                        <a:rPr lang="en-US" dirty="0"/>
+                        <a:t>Verify Reservation Details Expand</a:t>
+                      </a:r>
+                    </a:p>
+                  </a:txBody>
+                  <a:tcPr/>
+                </a:tc>
+                <a:tc>
+                  <a:txBody>
+                    <a:bodyPr/>
+                    <a:lstStyle/>
+                    <a:p>
+                      <a:endParaRPr lang="en-US"/>
+                    </a:p>
+                  </a:txBody>
+                  <a:tcPr/>
+                </a:tc>
+                <a:extLst>
+                  <a:ext uri="{0D108BD9-81ED-4DB2-BD59-A6C34878D82A}">
+                    <a16:rowId xmlns:a16="http://schemas.microsoft.com/office/drawing/2014/main" val="3993012492"/>
+                  </a:ext>
+                </a:extLst>
+              </a:tr>
+              <a:tr h="794456">
+                <a:tc>
+                  <a:txBody>
+                    <a:bodyPr/>
+                    <a:lstStyle/>
+                    <a:p>
+                      <a:r>
+                        <a:rPr lang="en-US" dirty="0"/>
+                        <a:t>About Page Loads with Merged Contact Section</a:t>
+                      </a:r>
+                    </a:p>
+                  </a:txBody>
+                  <a:tcPr/>
+                </a:tc>
+                <a:tc>
+                  <a:txBody>
+                    <a:bodyPr/>
+                    <a:lstStyle/>
+                    <a:p>
+                      <a:endParaRPr lang="en-US"/>
+                    </a:p>
+                  </a:txBody>
+                  <a:tcPr/>
+                </a:tc>
+                <a:extLst>
+                  <a:ext uri="{0D108BD9-81ED-4DB2-BD59-A6C34878D82A}">
+                    <a16:rowId xmlns:a16="http://schemas.microsoft.com/office/drawing/2014/main" val="2693675315"/>
+                  </a:ext>
+                </a:extLst>
+              </a:tr>
+              <a:tr h="794456">
+                <a:tc>
+                  <a:txBody>
+                    <a:bodyPr/>
+                    <a:lstStyle/>
+                    <a:p>
+                      <a:r>
+                        <a:rPr lang="en-US" dirty="0"/>
+                        <a:t>Room Available for Selected Dates</a:t>
+                      </a:r>
+                    </a:p>
+                  </a:txBody>
+                  <a:tcPr/>
+                </a:tc>
+                <a:tc>
+                  <a:txBody>
+                    <a:bodyPr/>
+                    <a:lstStyle/>
+                    <a:p>
+                      <a:endParaRPr lang="en-US" dirty="0"/>
+                    </a:p>
+                  </a:txBody>
+                  <a:tcPr/>
+                </a:tc>
+                <a:extLst>
+                  <a:ext uri="{0D108BD9-81ED-4DB2-BD59-A6C34878D82A}">
+                    <a16:rowId xmlns:a16="http://schemas.microsoft.com/office/drawing/2014/main" val="1066367883"/>
+                  </a:ext>
+                </a:extLst>
+              </a:tr>
+              <a:tr h="794456">
+                <a:tc>
+                  <a:txBody>
+                    <a:bodyPr/>
+                    <a:lstStyle/>
+                    <a:p>
+                      <a:r>
+                        <a:rPr lang="en-US" dirty="0"/>
+                        <a:t>Insufficient Rooms Are Rejected</a:t>
+                      </a:r>
+                    </a:p>
+                  </a:txBody>
+                  <a:tcPr/>
+                </a:tc>
+                <a:tc>
+                  <a:txBody>
+                    <a:bodyPr/>
+                    <a:lstStyle/>
+                    <a:p>
+                      <a:endParaRPr lang="en-US" dirty="0"/>
+                    </a:p>
+                  </a:txBody>
+                  <a:tcPr/>
+                </a:tc>
+                <a:extLst>
+                  <a:ext uri="{0D108BD9-81ED-4DB2-BD59-A6C34878D82A}">
+                    <a16:rowId xmlns:a16="http://schemas.microsoft.com/office/drawing/2014/main" val="2926638235"/>
+                  </a:ext>
+                </a:extLst>
+              </a:tr>
+            </a:tbl>
+          </a:graphicData>
+        </a:graphic>
+      </p:graphicFrame>
+      <p:pic>
+        <p:nvPicPr>
+          <p:cNvPr id="9" name="Picture 8" descr="Reservation History | Moffat Bay Lodge - Google Chrome">
+            <a:extLst>
+              <a:ext uri="{FF2B5EF4-FFF2-40B4-BE49-F238E27FC236}">
+                <a16:creationId xmlns:a16="http://schemas.microsoft.com/office/drawing/2014/main" id="{84539313-DDE6-AE28-1785-8C4282073F9B}"/>
+              </a:ext>
+            </a:extLst>
+          </p:cNvPr>
+          <p:cNvPicPr>
+            <a:picLocks noChangeAspect="1"/>
+          </p:cNvPicPr>
+          <p:nvPr/>
+        </p:nvPicPr>
+        <p:blipFill>
+          <a:blip r:embed="rId2" cstate="print">
+            <a:extLst>
+              <a:ext uri="{28A0092B-C50C-407E-A947-70E740481C1C}">
+                <a14:useLocalDpi xmlns:a14="http://schemas.microsoft.com/office/drawing/2010/main" val="0"/>
+              </a:ext>
+            </a:extLst>
+          </a:blip>
+          <a:stretch>
+            <a:fillRect/>
+          </a:stretch>
+        </p:blipFill>
+        <p:spPr>
+          <a:xfrm>
+            <a:off x="6160738" y="2297604"/>
+            <a:ext cx="1875282" cy="998491"/>
+          </a:xfrm>
+          <a:prstGeom prst="rect">
+            <a:avLst/>
+          </a:prstGeom>
+        </p:spPr>
+      </p:pic>
+      <p:pic>
+        <p:nvPicPr>
+          <p:cNvPr id="10" name="Picture 9" descr="Reservation History | Moffat Bay Lodge - Google Chrome">
+            <a:extLst>
+              <a:ext uri="{FF2B5EF4-FFF2-40B4-BE49-F238E27FC236}">
+                <a16:creationId xmlns:a16="http://schemas.microsoft.com/office/drawing/2014/main" id="{EA37D495-CACE-B91F-A041-2730A76DB827}"/>
+              </a:ext>
+            </a:extLst>
+          </p:cNvPr>
+          <p:cNvPicPr>
+            <a:picLocks noChangeAspect="1"/>
+          </p:cNvPicPr>
+          <p:nvPr/>
+        </p:nvPicPr>
+        <p:blipFill>
+          <a:blip r:embed="rId3" cstate="print">
+            <a:extLst>
+              <a:ext uri="{28A0092B-C50C-407E-A947-70E740481C1C}">
+                <a14:useLocalDpi xmlns:a14="http://schemas.microsoft.com/office/drawing/2010/main" val="0"/>
+              </a:ext>
+            </a:extLst>
+          </a:blip>
+          <a:stretch>
+            <a:fillRect/>
+          </a:stretch>
+        </p:blipFill>
+        <p:spPr>
+          <a:xfrm>
+            <a:off x="9107425" y="2663159"/>
+            <a:ext cx="2377439" cy="1265872"/>
+          </a:xfrm>
+          <a:prstGeom prst="rect">
+            <a:avLst/>
+          </a:prstGeom>
+        </p:spPr>
+      </p:pic>
+      <p:pic>
+        <p:nvPicPr>
+          <p:cNvPr id="11" name="Picture 10">
+            <a:extLst>
+              <a:ext uri="{FF2B5EF4-FFF2-40B4-BE49-F238E27FC236}">
+                <a16:creationId xmlns:a16="http://schemas.microsoft.com/office/drawing/2014/main" id="{1C70C928-7B41-D706-D843-305201ED8CAF}"/>
+              </a:ext>
+            </a:extLst>
+          </p:cNvPr>
+          <p:cNvPicPr>
+            <a:picLocks noChangeAspect="1"/>
+          </p:cNvPicPr>
+          <p:nvPr/>
+        </p:nvPicPr>
+        <p:blipFill>
+          <a:blip r:embed="rId4"/>
+          <a:stretch>
+            <a:fillRect/>
+          </a:stretch>
+        </p:blipFill>
+        <p:spPr>
+          <a:xfrm>
+            <a:off x="6160739" y="3953426"/>
+            <a:ext cx="1776254" cy="895371"/>
+          </a:xfrm>
+          <a:prstGeom prst="rect">
+            <a:avLst/>
+          </a:prstGeom>
+        </p:spPr>
+      </p:pic>
+      <p:pic>
+        <p:nvPicPr>
+          <p:cNvPr id="12" name="Picture 11">
+            <a:extLst>
+              <a:ext uri="{FF2B5EF4-FFF2-40B4-BE49-F238E27FC236}">
+                <a16:creationId xmlns:a16="http://schemas.microsoft.com/office/drawing/2014/main" id="{FD73EE82-C170-BB81-5ACA-04EBA54A1314}"/>
+              </a:ext>
+            </a:extLst>
+          </p:cNvPr>
+          <p:cNvPicPr>
+            <a:picLocks noChangeAspect="1"/>
+          </p:cNvPicPr>
+          <p:nvPr/>
+        </p:nvPicPr>
+        <p:blipFill>
+          <a:blip r:embed="rId5"/>
+          <a:stretch>
+            <a:fillRect/>
+          </a:stretch>
+        </p:blipFill>
+        <p:spPr>
+          <a:xfrm>
+            <a:off x="9107424" y="4305681"/>
+            <a:ext cx="2377440" cy="1191642"/>
+          </a:xfrm>
+          <a:prstGeom prst="rect">
+            <a:avLst/>
+          </a:prstGeom>
+        </p:spPr>
+      </p:pic>
+      <p:pic>
+        <p:nvPicPr>
+          <p:cNvPr id="15" name="Picture 14">
+            <a:extLst>
+              <a:ext uri="{FF2B5EF4-FFF2-40B4-BE49-F238E27FC236}">
+                <a16:creationId xmlns:a16="http://schemas.microsoft.com/office/drawing/2014/main" id="{70C9E551-5F92-DE6E-9DDA-09B36A83100C}"/>
+              </a:ext>
+            </a:extLst>
+          </p:cNvPr>
+          <p:cNvPicPr>
+            <a:picLocks noChangeAspect="1"/>
+          </p:cNvPicPr>
+          <p:nvPr/>
+        </p:nvPicPr>
+        <p:blipFill>
+          <a:blip r:embed="rId6"/>
+          <a:stretch>
+            <a:fillRect/>
+          </a:stretch>
+        </p:blipFill>
+        <p:spPr>
+          <a:xfrm>
+            <a:off x="6160738" y="5221416"/>
+            <a:ext cx="2206434" cy="1115378"/>
+          </a:xfrm>
+          <a:prstGeom prst="rect">
+            <a:avLst/>
+          </a:prstGeom>
+        </p:spPr>
+      </p:pic>
+    </p:spTree>
+    <p:extLst>
+      <p:ext uri="{BB962C8B-B14F-4D97-AF65-F5344CB8AC3E}">
+        <p14:creationId xmlns:p14="http://schemas.microsoft.com/office/powerpoint/2010/main" val="2388855564"/>
+      </p:ext>
+    </p:extLst>
+  </p:cSld>
+  <p:clrMapOvr>
+    <a:masterClrMapping/>
+  </p:clrMapOvr>
+</p:sld>
+</file>
+
+<file path=ppt/slides/slide15.xml><?xml version="1.0" encoding="utf-8"?>
+<p:sld xmlns:a="http://schemas.openxmlformats.org/drawingml/2006/main" xmlns:r="http://schemas.openxmlformats.org/officeDocument/2006/relationships" xmlns:p="http://schemas.openxmlformats.org/presentationml/2006/main">
+  <p:cSld>
+    <p:spTree>
+      <p:nvGrpSpPr>
+        <p:cNvPr id="1" name=""/>
+        <p:cNvGrpSpPr/>
+        <p:nvPr/>
+      </p:nvGrpSpPr>
+      <p:grpSpPr>
+        <a:xfrm>
+          <a:off x="0" y="0"/>
+          <a:ext cx="0" cy="0"/>
+          <a:chOff x="0" y="0"/>
+          <a:chExt cx="0" cy="0"/>
+        </a:xfrm>
+      </p:grpSpPr>
+      <p:sp>
+        <p:nvSpPr>
+          <p:cNvPr id="7" name="Title 6">
+            <a:extLst>
+              <a:ext uri="{FF2B5EF4-FFF2-40B4-BE49-F238E27FC236}">
+                <a16:creationId xmlns:a16="http://schemas.microsoft.com/office/drawing/2014/main" id="{826E1880-E19A-5FD8-D055-58E8FB76ECF2}"/>
+              </a:ext>
+            </a:extLst>
+          </p:cNvPr>
+          <p:cNvSpPr>
+            <a:spLocks noGrp="1"/>
+          </p:cNvSpPr>
+          <p:nvPr>
+            <p:ph type="title"/>
+          </p:nvPr>
+        </p:nvSpPr>
+        <p:spPr/>
+        <p:txBody>
+          <a:bodyPr/>
+          <a:lstStyle/>
+          <a:p>
+            <a:r>
+              <a:rPr lang="en-US" dirty="0"/>
+              <a:t>Team Lessons Learned</a:t>
+            </a:r>
+          </a:p>
+        </p:txBody>
+      </p:sp>
+      <p:sp>
+        <p:nvSpPr>
+          <p:cNvPr id="8" name="Content Placeholder 7">
+            <a:extLst>
+              <a:ext uri="{FF2B5EF4-FFF2-40B4-BE49-F238E27FC236}">
+                <a16:creationId xmlns:a16="http://schemas.microsoft.com/office/drawing/2014/main" id="{25941970-8ACA-A8F5-C91C-95EAD6E9F1A1}"/>
+              </a:ext>
+            </a:extLst>
+          </p:cNvPr>
+          <p:cNvSpPr>
+            <a:spLocks noGrp="1"/>
+          </p:cNvSpPr>
+          <p:nvPr>
+            <p:ph idx="1"/>
+          </p:nvPr>
+        </p:nvSpPr>
+        <p:spPr/>
+        <p:txBody>
+          <a:bodyPr/>
+          <a:lstStyle/>
+          <a:p>
+            <a:r>
+              <a:rPr lang="en-US" dirty="0"/>
+              <a:t>Communication is key for Async work</a:t>
+            </a:r>
+          </a:p>
+          <a:p>
+            <a:r>
+              <a:rPr lang="en-US" dirty="0"/>
+              <a:t>Always have a back up ready incase someone is unable to complete work</a:t>
+            </a:r>
+          </a:p>
+          <a:p>
+            <a:r>
+              <a:rPr lang="en-US" dirty="0"/>
+              <a:t>QA is important</a:t>
+            </a:r>
+          </a:p>
+          <a:p>
+            <a:r>
+              <a:rPr lang="en-US"/>
+              <a:t> PLEASE ADD MORE EVERYONE</a:t>
+            </a:r>
+          </a:p>
+        </p:txBody>
+      </p:sp>
+    </p:spTree>
+    <p:extLst>
+      <p:ext uri="{BB962C8B-B14F-4D97-AF65-F5344CB8AC3E}">
+        <p14:creationId xmlns:p14="http://schemas.microsoft.com/office/powerpoint/2010/main" val="3797506827"/>
+      </p:ext>
+    </p:extLst>
   </p:cSld>
   <p:clrMapOvr>
     <a:masterClrMapping/>

</xml_diff>

<commit_message>
Update README links and add presentation files to docs (#133)
Inital work for #110
</commit_message>
<xml_diff>
--- a/docs/Prototype.pptx
+++ b/docs/Prototype.pptx
@@ -5,7 +5,7 @@
     <p:sldMasterId id="2147483648" r:id="rId1"/>
   </p:sldMasterIdLst>
   <p:notesMasterIdLst>
-    <p:notesMasterId r:id="rId14"/>
+    <p:notesMasterId r:id="rId17"/>
   </p:notesMasterIdLst>
   <p:sldIdLst>
     <p:sldId id="256" r:id="rId2"/>
@@ -20,6 +20,9 @@
     <p:sldId id="265" r:id="rId11"/>
     <p:sldId id="266" r:id="rId12"/>
     <p:sldId id="267" r:id="rId13"/>
+    <p:sldId id="268" r:id="rId14"/>
+    <p:sldId id="269" r:id="rId15"/>
+    <p:sldId id="270" r:id="rId16"/>
   </p:sldIdLst>
   <p:sldSz cx="12192000" cy="6858000"/>
   <p:notesSz cx="6858000" cy="9144000"/>
@@ -208,7 +211,7 @@
           <a:p>
             <a:fld id="{3635DB15-7D6E-4472-B99D-9906CF1DE234}" type="datetimeFigureOut">
               <a:rPr lang="en-US" smtClean="0"/>
-              <a:t>8/19/2026</a:t>
+              <a:t>9/21/2026</a:t>
             </a:fld>
             <a:endParaRPr lang="en-US"/>
           </a:p>
@@ -1630,7 +1633,7 @@
           <a:p>
             <a:fld id="{DD5FEBA2-C475-4F4F-B1DA-6AC3BCF25491}" type="datetimeFigureOut">
               <a:rPr lang="en-US" smtClean="0"/>
-              <a:t>8/19/2026</a:t>
+              <a:t>9/21/2026</a:t>
             </a:fld>
             <a:endParaRPr lang="en-US"/>
           </a:p>
@@ -1828,7 +1831,7 @@
           <a:p>
             <a:fld id="{DD5FEBA2-C475-4F4F-B1DA-6AC3BCF25491}" type="datetimeFigureOut">
               <a:rPr lang="en-US" smtClean="0"/>
-              <a:t>8/19/2026</a:t>
+              <a:t>9/21/2026</a:t>
             </a:fld>
             <a:endParaRPr lang="en-US"/>
           </a:p>
@@ -2036,7 +2039,7 @@
           <a:p>
             <a:fld id="{DD5FEBA2-C475-4F4F-B1DA-6AC3BCF25491}" type="datetimeFigureOut">
               <a:rPr lang="en-US" smtClean="0"/>
-              <a:t>8/19/2026</a:t>
+              <a:t>9/21/2026</a:t>
             </a:fld>
             <a:endParaRPr lang="en-US"/>
           </a:p>
@@ -2269,7 +2272,7 @@
           <a:p>
             <a:fld id="{DD5FEBA2-C475-4F4F-B1DA-6AC3BCF25491}" type="datetimeFigureOut">
               <a:rPr lang="en-US" smtClean="0"/>
-              <a:t>8/19/2026</a:t>
+              <a:t>9/21/2026</a:t>
             </a:fld>
             <a:endParaRPr lang="en-US"/>
           </a:p>
@@ -2544,7 +2547,7 @@
           <a:p>
             <a:fld id="{DD5FEBA2-C475-4F4F-B1DA-6AC3BCF25491}" type="datetimeFigureOut">
               <a:rPr lang="en-US" smtClean="0"/>
-              <a:t>8/19/2026</a:t>
+              <a:t>9/21/2026</a:t>
             </a:fld>
             <a:endParaRPr lang="en-US"/>
           </a:p>
@@ -2809,7 +2812,7 @@
           <a:p>
             <a:fld id="{DD5FEBA2-C475-4F4F-B1DA-6AC3BCF25491}" type="datetimeFigureOut">
               <a:rPr lang="en-US" smtClean="0"/>
-              <a:t>8/19/2026</a:t>
+              <a:t>9/21/2026</a:t>
             </a:fld>
             <a:endParaRPr lang="en-US"/>
           </a:p>
@@ -3221,7 +3224,7 @@
           <a:p>
             <a:fld id="{DD5FEBA2-C475-4F4F-B1DA-6AC3BCF25491}" type="datetimeFigureOut">
               <a:rPr lang="en-US" smtClean="0"/>
-              <a:t>8/19/2026</a:t>
+              <a:t>9/21/2026</a:t>
             </a:fld>
             <a:endParaRPr lang="en-US"/>
           </a:p>
@@ -3362,7 +3365,7 @@
           <a:p>
             <a:fld id="{DD5FEBA2-C475-4F4F-B1DA-6AC3BCF25491}" type="datetimeFigureOut">
               <a:rPr lang="en-US" smtClean="0"/>
-              <a:t>8/19/2026</a:t>
+              <a:t>9/21/2026</a:t>
             </a:fld>
             <a:endParaRPr lang="en-US"/>
           </a:p>
@@ -3475,7 +3478,7 @@
           <a:p>
             <a:fld id="{DD5FEBA2-C475-4F4F-B1DA-6AC3BCF25491}" type="datetimeFigureOut">
               <a:rPr lang="en-US" smtClean="0"/>
-              <a:t>8/19/2026</a:t>
+              <a:t>9/21/2026</a:t>
             </a:fld>
             <a:endParaRPr lang="en-US"/>
           </a:p>
@@ -3786,7 +3789,7 @@
           <a:p>
             <a:fld id="{DD5FEBA2-C475-4F4F-B1DA-6AC3BCF25491}" type="datetimeFigureOut">
               <a:rPr lang="en-US" smtClean="0"/>
-              <a:t>8/19/2026</a:t>
+              <a:t>9/21/2026</a:t>
             </a:fld>
             <a:endParaRPr lang="en-US"/>
           </a:p>
@@ -4074,7 +4077,7 @@
           <a:p>
             <a:fld id="{DD5FEBA2-C475-4F4F-B1DA-6AC3BCF25491}" type="datetimeFigureOut">
               <a:rPr lang="en-US" smtClean="0"/>
-              <a:t>8/19/2026</a:t>
+              <a:t>9/21/2026</a:t>
             </a:fld>
             <a:endParaRPr lang="en-US"/>
           </a:p>
@@ -4315,7 +4318,7 @@
           <a:p>
             <a:fld id="{DD5FEBA2-C475-4F4F-B1DA-6AC3BCF25491}" type="datetimeFigureOut">
               <a:rPr lang="en-US" smtClean="0"/>
-              <a:t>8/19/2026</a:t>
+              <a:t>9/21/2026</a:t>
             </a:fld>
             <a:endParaRPr lang="en-US"/>
           </a:p>
@@ -13915,6 +13918,658 @@
         </p:txBody>
       </p:sp>
     </p:spTree>
+  </p:cSld>
+  <p:clrMapOvr>
+    <a:masterClrMapping/>
+  </p:clrMapOvr>
+</p:sld>
+</file>
+
+<file path=ppt/slides/slide13.xml><?xml version="1.0" encoding="utf-8"?>
+<p:sld xmlns:a="http://schemas.openxmlformats.org/drawingml/2006/main" xmlns:r="http://schemas.openxmlformats.org/officeDocument/2006/relationships" xmlns:p="http://schemas.openxmlformats.org/presentationml/2006/main">
+  <p:cSld>
+    <p:spTree>
+      <p:nvGrpSpPr>
+        <p:cNvPr id="1" name=""/>
+        <p:cNvGrpSpPr/>
+        <p:nvPr/>
+      </p:nvGrpSpPr>
+      <p:grpSpPr>
+        <a:xfrm>
+          <a:off x="0" y="0"/>
+          <a:ext cx="0" cy="0"/>
+          <a:chOff x="0" y="0"/>
+          <a:chExt cx="0" cy="0"/>
+        </a:xfrm>
+      </p:grpSpPr>
+      <p:sp>
+        <p:nvSpPr>
+          <p:cNvPr id="2" name="TextBox 1">
+            <a:extLst>
+              <a:ext uri="{FF2B5EF4-FFF2-40B4-BE49-F238E27FC236}">
+                <a16:creationId xmlns:a16="http://schemas.microsoft.com/office/drawing/2014/main" id="{B11A5918-99AF-6C39-B685-05D56B64D7E2}"/>
+              </a:ext>
+            </a:extLst>
+          </p:cNvPr>
+          <p:cNvSpPr txBox="1"/>
+          <p:nvPr/>
+        </p:nvSpPr>
+        <p:spPr>
+          <a:xfrm>
+            <a:off x="1179576" y="713232"/>
+            <a:ext cx="611065" cy="369332"/>
+          </a:xfrm>
+          <a:prstGeom prst="rect">
+            <a:avLst/>
+          </a:prstGeom>
+          <a:noFill/>
+        </p:spPr>
+        <p:txBody>
+          <a:bodyPr wrap="none" rtlCol="0">
+            <a:spAutoFit/>
+          </a:bodyPr>
+          <a:lstStyle/>
+          <a:p>
+            <a:r>
+              <a:rPr lang="en-US" dirty="0"/>
+              <a:t>ERD</a:t>
+            </a:r>
+          </a:p>
+        </p:txBody>
+      </p:sp>
+      <p:pic>
+        <p:nvPicPr>
+          <p:cNvPr id="6" name="Picture 5">
+            <a:extLst>
+              <a:ext uri="{FF2B5EF4-FFF2-40B4-BE49-F238E27FC236}">
+                <a16:creationId xmlns:a16="http://schemas.microsoft.com/office/drawing/2014/main" id="{5762FB90-FE35-F282-DBA2-FB2E6AC7924F}"/>
+              </a:ext>
+            </a:extLst>
+          </p:cNvPr>
+          <p:cNvPicPr>
+            <a:picLocks noChangeAspect="1"/>
+          </p:cNvPicPr>
+          <p:nvPr/>
+        </p:nvPicPr>
+        <p:blipFill>
+          <a:blip r:embed="rId2"/>
+          <a:stretch>
+            <a:fillRect/>
+          </a:stretch>
+        </p:blipFill>
+        <p:spPr>
+          <a:xfrm>
+            <a:off x="5291471" y="358845"/>
+            <a:ext cx="6144482" cy="6268325"/>
+          </a:xfrm>
+          <a:prstGeom prst="rect">
+            <a:avLst/>
+          </a:prstGeom>
+        </p:spPr>
+      </p:pic>
+    </p:spTree>
+    <p:extLst>
+      <p:ext uri="{BB962C8B-B14F-4D97-AF65-F5344CB8AC3E}">
+        <p14:creationId xmlns:p14="http://schemas.microsoft.com/office/powerpoint/2010/main" val="4215458631"/>
+      </p:ext>
+    </p:extLst>
+  </p:cSld>
+  <p:clrMapOvr>
+    <a:masterClrMapping/>
+  </p:clrMapOvr>
+</p:sld>
+</file>
+
+<file path=ppt/slides/slide14.xml><?xml version="1.0" encoding="utf-8"?>
+<p:sld xmlns:a="http://schemas.openxmlformats.org/drawingml/2006/main" xmlns:r="http://schemas.openxmlformats.org/officeDocument/2006/relationships" xmlns:p="http://schemas.openxmlformats.org/presentationml/2006/main">
+  <p:cSld>
+    <p:spTree>
+      <p:nvGrpSpPr>
+        <p:cNvPr id="1" name=""/>
+        <p:cNvGrpSpPr/>
+        <p:nvPr/>
+      </p:nvGrpSpPr>
+      <p:grpSpPr>
+        <a:xfrm>
+          <a:off x="0" y="0"/>
+          <a:ext cx="0" cy="0"/>
+          <a:chOff x="0" y="0"/>
+          <a:chExt cx="0" cy="0"/>
+        </a:xfrm>
+      </p:grpSpPr>
+      <p:sp>
+        <p:nvSpPr>
+          <p:cNvPr id="3" name="Title 2">
+            <a:extLst>
+              <a:ext uri="{FF2B5EF4-FFF2-40B4-BE49-F238E27FC236}">
+                <a16:creationId xmlns:a16="http://schemas.microsoft.com/office/drawing/2014/main" id="{F0D51221-4031-16CF-9492-E5678E8C135F}"/>
+              </a:ext>
+            </a:extLst>
+          </p:cNvPr>
+          <p:cNvSpPr>
+            <a:spLocks noGrp="1"/>
+          </p:cNvSpPr>
+          <p:nvPr>
+            <p:ph type="title"/>
+          </p:nvPr>
+        </p:nvSpPr>
+        <p:spPr/>
+        <p:txBody>
+          <a:bodyPr/>
+          <a:lstStyle/>
+          <a:p>
+            <a:r>
+              <a:rPr lang="en-US" dirty="0"/>
+              <a:t>Tests Created</a:t>
+            </a:r>
+          </a:p>
+        </p:txBody>
+      </p:sp>
+      <p:graphicFrame>
+        <p:nvGraphicFramePr>
+          <p:cNvPr id="8" name="Table 7">
+            <a:extLst>
+              <a:ext uri="{FF2B5EF4-FFF2-40B4-BE49-F238E27FC236}">
+                <a16:creationId xmlns:a16="http://schemas.microsoft.com/office/drawing/2014/main" id="{E6BBA3F8-CF92-0CAE-DA0B-BEA11696DE8D}"/>
+              </a:ext>
+            </a:extLst>
+          </p:cNvPr>
+          <p:cNvGraphicFramePr>
+            <a:graphicFrameLocks noGrp="1"/>
+          </p:cNvGraphicFramePr>
+          <p:nvPr>
+            <p:extLst>
+              <p:ext uri="{D42A27DB-BD31-4B8C-83A1-F6EECF244321}">
+                <p14:modId xmlns:p14="http://schemas.microsoft.com/office/powerpoint/2010/main" val="3433709969"/>
+              </p:ext>
+            </p:extLst>
+          </p:nvPr>
+        </p:nvGraphicFramePr>
+        <p:xfrm>
+          <a:off x="836612" y="1570058"/>
+          <a:ext cx="10648252" cy="4766736"/>
+        </p:xfrm>
+        <a:graphic>
+          <a:graphicData uri="http://schemas.openxmlformats.org/drawingml/2006/table">
+            <a:tbl>
+              <a:tblPr firstRow="1" bandRow="1">
+                <a:tableStyleId>{5C22544A-7EE6-4342-B048-85BDC9FD1C3A}</a:tableStyleId>
+              </a:tblPr>
+              <a:tblGrid>
+                <a:gridCol w="5324126">
+                  <a:extLst>
+                    <a:ext uri="{9D8B030D-6E8A-4147-A177-3AD203B41FA5}">
+                      <a16:colId xmlns:a16="http://schemas.microsoft.com/office/drawing/2014/main" val="1350263101"/>
+                    </a:ext>
+                  </a:extLst>
+                </a:gridCol>
+                <a:gridCol w="5324126">
+                  <a:extLst>
+                    <a:ext uri="{9D8B030D-6E8A-4147-A177-3AD203B41FA5}">
+                      <a16:colId xmlns:a16="http://schemas.microsoft.com/office/drawing/2014/main" val="1308490610"/>
+                    </a:ext>
+                  </a:extLst>
+                </a:gridCol>
+              </a:tblGrid>
+              <a:tr h="794456">
+                <a:tc>
+                  <a:txBody>
+                    <a:bodyPr/>
+                    <a:lstStyle/>
+                    <a:p>
+                      <a:r>
+                        <a:rPr lang="en-US" dirty="0"/>
+                        <a:t>Test Name/Description</a:t>
+                      </a:r>
+                    </a:p>
+                  </a:txBody>
+                  <a:tcPr/>
+                </a:tc>
+                <a:tc>
+                  <a:txBody>
+                    <a:bodyPr/>
+                    <a:lstStyle/>
+                    <a:p>
+                      <a:r>
+                        <a:rPr lang="en-US" dirty="0"/>
+                        <a:t>Result</a:t>
+                      </a:r>
+                    </a:p>
+                  </a:txBody>
+                  <a:tcPr/>
+                </a:tc>
+                <a:extLst>
+                  <a:ext uri="{0D108BD9-81ED-4DB2-BD59-A6C34878D82A}">
+                    <a16:rowId xmlns:a16="http://schemas.microsoft.com/office/drawing/2014/main" val="1949477541"/>
+                  </a:ext>
+                </a:extLst>
+              </a:tr>
+              <a:tr h="794456">
+                <a:tc>
+                  <a:txBody>
+                    <a:bodyPr/>
+                    <a:lstStyle/>
+                    <a:p>
+                      <a:r>
+                        <a:rPr lang="en-US" dirty="0"/>
+                        <a:t>Verify Reservation Lookup Connects to the Database</a:t>
+                      </a:r>
+                    </a:p>
+                  </a:txBody>
+                  <a:tcPr/>
+                </a:tc>
+                <a:tc>
+                  <a:txBody>
+                    <a:bodyPr/>
+                    <a:lstStyle/>
+                    <a:p>
+                      <a:endParaRPr lang="en-US" dirty="0"/>
+                    </a:p>
+                  </a:txBody>
+                  <a:tcPr/>
+                </a:tc>
+                <a:extLst>
+                  <a:ext uri="{0D108BD9-81ED-4DB2-BD59-A6C34878D82A}">
+                    <a16:rowId xmlns:a16="http://schemas.microsoft.com/office/drawing/2014/main" val="3627560426"/>
+                  </a:ext>
+                </a:extLst>
+              </a:tr>
+              <a:tr h="794456">
+                <a:tc>
+                  <a:txBody>
+                    <a:bodyPr/>
+                    <a:lstStyle/>
+                    <a:p>
+                      <a:r>
+                        <a:rPr lang="en-US" dirty="0"/>
+                        <a:t>Verify Reservation Details Expand</a:t>
+                      </a:r>
+                    </a:p>
+                  </a:txBody>
+                  <a:tcPr/>
+                </a:tc>
+                <a:tc>
+                  <a:txBody>
+                    <a:bodyPr/>
+                    <a:lstStyle/>
+                    <a:p>
+                      <a:endParaRPr lang="en-US"/>
+                    </a:p>
+                  </a:txBody>
+                  <a:tcPr/>
+                </a:tc>
+                <a:extLst>
+                  <a:ext uri="{0D108BD9-81ED-4DB2-BD59-A6C34878D82A}">
+                    <a16:rowId xmlns:a16="http://schemas.microsoft.com/office/drawing/2014/main" val="3993012492"/>
+                  </a:ext>
+                </a:extLst>
+              </a:tr>
+              <a:tr h="794456">
+                <a:tc>
+                  <a:txBody>
+                    <a:bodyPr/>
+                    <a:lstStyle/>
+                    <a:p>
+                      <a:r>
+                        <a:rPr lang="en-US" dirty="0"/>
+                        <a:t>About Page Loads with Merged Contact Section</a:t>
+                      </a:r>
+                    </a:p>
+                  </a:txBody>
+                  <a:tcPr/>
+                </a:tc>
+                <a:tc>
+                  <a:txBody>
+                    <a:bodyPr/>
+                    <a:lstStyle/>
+                    <a:p>
+                      <a:endParaRPr lang="en-US"/>
+                    </a:p>
+                  </a:txBody>
+                  <a:tcPr/>
+                </a:tc>
+                <a:extLst>
+                  <a:ext uri="{0D108BD9-81ED-4DB2-BD59-A6C34878D82A}">
+                    <a16:rowId xmlns:a16="http://schemas.microsoft.com/office/drawing/2014/main" val="2693675315"/>
+                  </a:ext>
+                </a:extLst>
+              </a:tr>
+              <a:tr h="794456">
+                <a:tc>
+                  <a:txBody>
+                    <a:bodyPr/>
+                    <a:lstStyle/>
+                    <a:p>
+                      <a:r>
+                        <a:rPr lang="en-US" dirty="0"/>
+                        <a:t>Room Available for Selected Dates</a:t>
+                      </a:r>
+                    </a:p>
+                  </a:txBody>
+                  <a:tcPr/>
+                </a:tc>
+                <a:tc>
+                  <a:txBody>
+                    <a:bodyPr/>
+                    <a:lstStyle/>
+                    <a:p>
+                      <a:endParaRPr lang="en-US" dirty="0"/>
+                    </a:p>
+                  </a:txBody>
+                  <a:tcPr/>
+                </a:tc>
+                <a:extLst>
+                  <a:ext uri="{0D108BD9-81ED-4DB2-BD59-A6C34878D82A}">
+                    <a16:rowId xmlns:a16="http://schemas.microsoft.com/office/drawing/2014/main" val="1066367883"/>
+                  </a:ext>
+                </a:extLst>
+              </a:tr>
+              <a:tr h="794456">
+                <a:tc>
+                  <a:txBody>
+                    <a:bodyPr/>
+                    <a:lstStyle/>
+                    <a:p>
+                      <a:r>
+                        <a:rPr lang="en-US" dirty="0"/>
+                        <a:t>Insufficient Rooms Are Rejected</a:t>
+                      </a:r>
+                    </a:p>
+                  </a:txBody>
+                  <a:tcPr/>
+                </a:tc>
+                <a:tc>
+                  <a:txBody>
+                    <a:bodyPr/>
+                    <a:lstStyle/>
+                    <a:p>
+                      <a:endParaRPr lang="en-US" dirty="0"/>
+                    </a:p>
+                  </a:txBody>
+                  <a:tcPr/>
+                </a:tc>
+                <a:extLst>
+                  <a:ext uri="{0D108BD9-81ED-4DB2-BD59-A6C34878D82A}">
+                    <a16:rowId xmlns:a16="http://schemas.microsoft.com/office/drawing/2014/main" val="2926638235"/>
+                  </a:ext>
+                </a:extLst>
+              </a:tr>
+            </a:tbl>
+          </a:graphicData>
+        </a:graphic>
+      </p:graphicFrame>
+      <p:pic>
+        <p:nvPicPr>
+          <p:cNvPr id="9" name="Picture 8" descr="Reservation History | Moffat Bay Lodge - Google Chrome">
+            <a:extLst>
+              <a:ext uri="{FF2B5EF4-FFF2-40B4-BE49-F238E27FC236}">
+                <a16:creationId xmlns:a16="http://schemas.microsoft.com/office/drawing/2014/main" id="{84539313-DDE6-AE28-1785-8C4282073F9B}"/>
+              </a:ext>
+            </a:extLst>
+          </p:cNvPr>
+          <p:cNvPicPr>
+            <a:picLocks noChangeAspect="1"/>
+          </p:cNvPicPr>
+          <p:nvPr/>
+        </p:nvPicPr>
+        <p:blipFill>
+          <a:blip r:embed="rId2" cstate="print">
+            <a:extLst>
+              <a:ext uri="{28A0092B-C50C-407E-A947-70E740481C1C}">
+                <a14:useLocalDpi xmlns:a14="http://schemas.microsoft.com/office/drawing/2010/main" val="0"/>
+              </a:ext>
+            </a:extLst>
+          </a:blip>
+          <a:stretch>
+            <a:fillRect/>
+          </a:stretch>
+        </p:blipFill>
+        <p:spPr>
+          <a:xfrm>
+            <a:off x="6160738" y="2297604"/>
+            <a:ext cx="1875282" cy="998491"/>
+          </a:xfrm>
+          <a:prstGeom prst="rect">
+            <a:avLst/>
+          </a:prstGeom>
+        </p:spPr>
+      </p:pic>
+      <p:pic>
+        <p:nvPicPr>
+          <p:cNvPr id="10" name="Picture 9" descr="Reservation History | Moffat Bay Lodge - Google Chrome">
+            <a:extLst>
+              <a:ext uri="{FF2B5EF4-FFF2-40B4-BE49-F238E27FC236}">
+                <a16:creationId xmlns:a16="http://schemas.microsoft.com/office/drawing/2014/main" id="{EA37D495-CACE-B91F-A041-2730A76DB827}"/>
+              </a:ext>
+            </a:extLst>
+          </p:cNvPr>
+          <p:cNvPicPr>
+            <a:picLocks noChangeAspect="1"/>
+          </p:cNvPicPr>
+          <p:nvPr/>
+        </p:nvPicPr>
+        <p:blipFill>
+          <a:blip r:embed="rId3" cstate="print">
+            <a:extLst>
+              <a:ext uri="{28A0092B-C50C-407E-A947-70E740481C1C}">
+                <a14:useLocalDpi xmlns:a14="http://schemas.microsoft.com/office/drawing/2010/main" val="0"/>
+              </a:ext>
+            </a:extLst>
+          </a:blip>
+          <a:stretch>
+            <a:fillRect/>
+          </a:stretch>
+        </p:blipFill>
+        <p:spPr>
+          <a:xfrm>
+            <a:off x="9107425" y="2663159"/>
+            <a:ext cx="2377439" cy="1265872"/>
+          </a:xfrm>
+          <a:prstGeom prst="rect">
+            <a:avLst/>
+          </a:prstGeom>
+        </p:spPr>
+      </p:pic>
+      <p:pic>
+        <p:nvPicPr>
+          <p:cNvPr id="11" name="Picture 10">
+            <a:extLst>
+              <a:ext uri="{FF2B5EF4-FFF2-40B4-BE49-F238E27FC236}">
+                <a16:creationId xmlns:a16="http://schemas.microsoft.com/office/drawing/2014/main" id="{1C70C928-7B41-D706-D843-305201ED8CAF}"/>
+              </a:ext>
+            </a:extLst>
+          </p:cNvPr>
+          <p:cNvPicPr>
+            <a:picLocks noChangeAspect="1"/>
+          </p:cNvPicPr>
+          <p:nvPr/>
+        </p:nvPicPr>
+        <p:blipFill>
+          <a:blip r:embed="rId4"/>
+          <a:stretch>
+            <a:fillRect/>
+          </a:stretch>
+        </p:blipFill>
+        <p:spPr>
+          <a:xfrm>
+            <a:off x="6160739" y="3953426"/>
+            <a:ext cx="1776254" cy="895371"/>
+          </a:xfrm>
+          <a:prstGeom prst="rect">
+            <a:avLst/>
+          </a:prstGeom>
+        </p:spPr>
+      </p:pic>
+      <p:pic>
+        <p:nvPicPr>
+          <p:cNvPr id="12" name="Picture 11">
+            <a:extLst>
+              <a:ext uri="{FF2B5EF4-FFF2-40B4-BE49-F238E27FC236}">
+                <a16:creationId xmlns:a16="http://schemas.microsoft.com/office/drawing/2014/main" id="{FD73EE82-C170-BB81-5ACA-04EBA54A1314}"/>
+              </a:ext>
+            </a:extLst>
+          </p:cNvPr>
+          <p:cNvPicPr>
+            <a:picLocks noChangeAspect="1"/>
+          </p:cNvPicPr>
+          <p:nvPr/>
+        </p:nvPicPr>
+        <p:blipFill>
+          <a:blip r:embed="rId5"/>
+          <a:stretch>
+            <a:fillRect/>
+          </a:stretch>
+        </p:blipFill>
+        <p:spPr>
+          <a:xfrm>
+            <a:off x="9107424" y="4305681"/>
+            <a:ext cx="2377440" cy="1191642"/>
+          </a:xfrm>
+          <a:prstGeom prst="rect">
+            <a:avLst/>
+          </a:prstGeom>
+        </p:spPr>
+      </p:pic>
+      <p:pic>
+        <p:nvPicPr>
+          <p:cNvPr id="15" name="Picture 14">
+            <a:extLst>
+              <a:ext uri="{FF2B5EF4-FFF2-40B4-BE49-F238E27FC236}">
+                <a16:creationId xmlns:a16="http://schemas.microsoft.com/office/drawing/2014/main" id="{70C9E551-5F92-DE6E-9DDA-09B36A83100C}"/>
+              </a:ext>
+            </a:extLst>
+          </p:cNvPr>
+          <p:cNvPicPr>
+            <a:picLocks noChangeAspect="1"/>
+          </p:cNvPicPr>
+          <p:nvPr/>
+        </p:nvPicPr>
+        <p:blipFill>
+          <a:blip r:embed="rId6"/>
+          <a:stretch>
+            <a:fillRect/>
+          </a:stretch>
+        </p:blipFill>
+        <p:spPr>
+          <a:xfrm>
+            <a:off x="6160738" y="5221416"/>
+            <a:ext cx="2206434" cy="1115378"/>
+          </a:xfrm>
+          <a:prstGeom prst="rect">
+            <a:avLst/>
+          </a:prstGeom>
+        </p:spPr>
+      </p:pic>
+    </p:spTree>
+    <p:extLst>
+      <p:ext uri="{BB962C8B-B14F-4D97-AF65-F5344CB8AC3E}">
+        <p14:creationId xmlns:p14="http://schemas.microsoft.com/office/powerpoint/2010/main" val="2388855564"/>
+      </p:ext>
+    </p:extLst>
+  </p:cSld>
+  <p:clrMapOvr>
+    <a:masterClrMapping/>
+  </p:clrMapOvr>
+</p:sld>
+</file>
+
+<file path=ppt/slides/slide15.xml><?xml version="1.0" encoding="utf-8"?>
+<p:sld xmlns:a="http://schemas.openxmlformats.org/drawingml/2006/main" xmlns:r="http://schemas.openxmlformats.org/officeDocument/2006/relationships" xmlns:p="http://schemas.openxmlformats.org/presentationml/2006/main">
+  <p:cSld>
+    <p:spTree>
+      <p:nvGrpSpPr>
+        <p:cNvPr id="1" name=""/>
+        <p:cNvGrpSpPr/>
+        <p:nvPr/>
+      </p:nvGrpSpPr>
+      <p:grpSpPr>
+        <a:xfrm>
+          <a:off x="0" y="0"/>
+          <a:ext cx="0" cy="0"/>
+          <a:chOff x="0" y="0"/>
+          <a:chExt cx="0" cy="0"/>
+        </a:xfrm>
+      </p:grpSpPr>
+      <p:sp>
+        <p:nvSpPr>
+          <p:cNvPr id="7" name="Title 6">
+            <a:extLst>
+              <a:ext uri="{FF2B5EF4-FFF2-40B4-BE49-F238E27FC236}">
+                <a16:creationId xmlns:a16="http://schemas.microsoft.com/office/drawing/2014/main" id="{826E1880-E19A-5FD8-D055-58E8FB76ECF2}"/>
+              </a:ext>
+            </a:extLst>
+          </p:cNvPr>
+          <p:cNvSpPr>
+            <a:spLocks noGrp="1"/>
+          </p:cNvSpPr>
+          <p:nvPr>
+            <p:ph type="title"/>
+          </p:nvPr>
+        </p:nvSpPr>
+        <p:spPr/>
+        <p:txBody>
+          <a:bodyPr/>
+          <a:lstStyle/>
+          <a:p>
+            <a:r>
+              <a:rPr lang="en-US" dirty="0"/>
+              <a:t>Team Lessons Learned</a:t>
+            </a:r>
+          </a:p>
+        </p:txBody>
+      </p:sp>
+      <p:sp>
+        <p:nvSpPr>
+          <p:cNvPr id="8" name="Content Placeholder 7">
+            <a:extLst>
+              <a:ext uri="{FF2B5EF4-FFF2-40B4-BE49-F238E27FC236}">
+                <a16:creationId xmlns:a16="http://schemas.microsoft.com/office/drawing/2014/main" id="{25941970-8ACA-A8F5-C91C-95EAD6E9F1A1}"/>
+              </a:ext>
+            </a:extLst>
+          </p:cNvPr>
+          <p:cNvSpPr>
+            <a:spLocks noGrp="1"/>
+          </p:cNvSpPr>
+          <p:nvPr>
+            <p:ph idx="1"/>
+          </p:nvPr>
+        </p:nvSpPr>
+        <p:spPr/>
+        <p:txBody>
+          <a:bodyPr/>
+          <a:lstStyle/>
+          <a:p>
+            <a:r>
+              <a:rPr lang="en-US" dirty="0"/>
+              <a:t>Communication is key for Async work</a:t>
+            </a:r>
+          </a:p>
+          <a:p>
+            <a:r>
+              <a:rPr lang="en-US" dirty="0"/>
+              <a:t>Always have a back up ready incase someone is unable to complete work</a:t>
+            </a:r>
+          </a:p>
+          <a:p>
+            <a:r>
+              <a:rPr lang="en-US" dirty="0"/>
+              <a:t>QA is important</a:t>
+            </a:r>
+          </a:p>
+          <a:p>
+            <a:r>
+              <a:rPr lang="en-US"/>
+              <a:t> PLEASE ADD MORE EVERYONE</a:t>
+            </a:r>
+          </a:p>
+        </p:txBody>
+      </p:sp>
+    </p:spTree>
+    <p:extLst>
+      <p:ext uri="{BB962C8B-B14F-4D97-AF65-F5344CB8AC3E}">
+        <p14:creationId xmlns:p14="http://schemas.microsoft.com/office/powerpoint/2010/main" val="3797506827"/>
+      </p:ext>
+    </p:extLst>
   </p:cSld>
   <p:clrMapOvr>
     <a:masterClrMapping/>

</xml_diff>